<commit_message>
chore(preview): regenerate MC.PA outputs with all patches applied
- TEMPLATE.xlsx: SCENARIOS year labels TEXT(), CF rules, formula fixes
- pptx_writer.py: Y-axis wrap fix, subtitle bullet guard

Co-Authored-By: Claude Sonnet 4.6 <noreply@anthropic.com>
</commit_message>
<xml_diff>
--- a/preview/MC.PA/MC.PA_pitchbook.pptx
+++ b/preview/MC.PA/MC.PA_pitchbook.pptx
@@ -6138,7 +6138,7 @@
                 </a:solidFill>
                 <a:latin typeface="Calibri"/>
               </a:rPr>
-              <a:t>Marge brute stable autour de 68% jusqu'en 2023 puis légère érosion à 66.2% en 2025 due aux coûts logistiques. Marge EBITDA à 32% en 2025 vs 34.6% en 2023 reflétant pression sur les coûts fixes. Marge nette en baisse de 17.8% en 2022 à 13.5% en 2025.</a:t>
+              <a:t>Les marges brutes passent de 68.8% en 2023 à 66.2% en 2025 (-2.6 pts) en raison des coûts logistiques et inflation. Les marges EBITDA et nettes se contractent respectivement de 2.6 pts et 4.3 pts sur la période, reflétant des investissements commerciaux et une hausse des coûts fixes.</a:t>
             </a:r>
           </a:p>
         </p:txBody>
@@ -9480,7 +9480,7 @@
                 </a:solidFill>
                 <a:latin typeface="Calibri"/>
               </a:rPr>
-              <a:t>WACC de 8.6% et TGR de 2.5% impliquent un upside de 13.5% sur la base du cours actuel de 458.3€.</a:t>
+              <a:t>WACC à 8.6% et TGR à 2.5% impliquent un upside de 14% vs cours actuel. Le DCF base donne un prix implicite de 520€, proche du cours actuel.</a:t>
             </a:r>
           </a:p>
         </p:txBody>
@@ -10544,7 +10544,7 @@
                           </a:solidFill>
                           <a:latin typeface="Calibri"/>
                         </a:rPr>
-                        <a:t>58,2</a:t>
+                        <a:t>72,5</a:t>
                       </a:r>
                     </a:p>
                   </a:txBody>
@@ -10567,7 +10567,7 @@
                           </a:solidFill>
                           <a:latin typeface="Calibri"/>
                         </a:rPr>
-                        <a:t>10,5x</a:t>
+                        <a:t>10,1x</a:t>
                       </a:r>
                     </a:p>
                   </a:txBody>
@@ -10590,7 +10590,7 @@
                           </a:solidFill>
                           <a:latin typeface="Calibri"/>
                         </a:rPr>
-                        <a:t>2,8x</a:t>
+                        <a:t>3,1x</a:t>
                       </a:r>
                     </a:p>
                   </a:txBody>
@@ -10613,7 +10613,7 @@
                           </a:solidFill>
                           <a:latin typeface="Calibri"/>
                         </a:rPr>
-                        <a:t>25,1x</a:t>
+                        <a:t>25,3x</a:t>
                       </a:r>
                     </a:p>
                   </a:txBody>
@@ -10636,7 +10636,7 @@
                           </a:solidFill>
                           <a:latin typeface="Calibri"/>
                         </a:rPr>
-                        <a:t>64,0 %</a:t>
+                        <a:t>65,0 %</a:t>
                       </a:r>
                     </a:p>
                   </a:txBody>
@@ -10684,7 +10684,7 @@
                           </a:solidFill>
                           <a:latin typeface="Calibri"/>
                         </a:rPr>
-                        <a:t>Hermès</a:t>
+                        <a:t>Richemont</a:t>
                       </a:r>
                     </a:p>
                   </a:txBody>
@@ -10707,7 +10707,7 @@
                           </a:solidFill>
                           <a:latin typeface="Calibri"/>
                         </a:rPr>
-                        <a:t>RMS.PA</a:t>
+                        <a:t>CFR.SW</a:t>
                       </a:r>
                     </a:p>
                   </a:txBody>
@@ -10730,7 +10730,7 @@
                           </a:solidFill>
                           <a:latin typeface="Calibri"/>
                         </a:rPr>
-                        <a:t>180,5</a:t>
+                        <a:t>58,2</a:t>
                       </a:r>
                     </a:p>
                   </a:txBody>
@@ -10753,7 +10753,7 @@
                           </a:solidFill>
                           <a:latin typeface="Calibri"/>
                         </a:rPr>
-                        <a:t>22,3x</a:t>
+                        <a:t>11,2x</a:t>
                       </a:r>
                     </a:p>
                   </a:txBody>
@@ -10776,7 +10776,7 @@
                           </a:solidFill>
                           <a:latin typeface="Calibri"/>
                         </a:rPr>
-                        <a:t>7,5x</a:t>
+                        <a:t>3,5x</a:t>
                       </a:r>
                     </a:p>
                   </a:txBody>
@@ -10799,7 +10799,7 @@
                           </a:solidFill>
                           <a:latin typeface="Calibri"/>
                         </a:rPr>
-                        <a:t>45,8x</a:t>
+                        <a:t>22,1x</a:t>
                       </a:r>
                     </a:p>
                   </a:txBody>
@@ -10822,7 +10822,7 @@
                           </a:solidFill>
                           <a:latin typeface="Calibri"/>
                         </a:rPr>
-                        <a:t>69,0 %</a:t>
+                        <a:t>67,0 %</a:t>
                       </a:r>
                     </a:p>
                   </a:txBody>
@@ -10845,7 +10845,7 @@
                           </a:solidFill>
                           <a:latin typeface="Calibri"/>
                         </a:rPr>
-                        <a:t>38,0 %</a:t>
+                        <a:t>31,0 %</a:t>
                       </a:r>
                     </a:p>
                   </a:txBody>
@@ -10870,7 +10870,7 @@
                           </a:solidFill>
                           <a:latin typeface="Calibri"/>
                         </a:rPr>
-                        <a:t>Richemont</a:t>
+                        <a:t>Hermès</a:t>
                       </a:r>
                     </a:p>
                   </a:txBody>
@@ -10893,7 +10893,7 @@
                           </a:solidFill>
                           <a:latin typeface="Calibri"/>
                         </a:rPr>
-                        <a:t>CFR.SW</a:t>
+                        <a:t>RMS.PA</a:t>
                       </a:r>
                     </a:p>
                   </a:txBody>
@@ -10916,7 +10916,7 @@
                           </a:solidFill>
                           <a:latin typeface="Calibri"/>
                         </a:rPr>
-                        <a:t>52,1</a:t>
+                        <a:t>185,0</a:t>
                       </a:r>
                     </a:p>
                   </a:txBody>
@@ -10939,7 +10939,7 @@
                           </a:solidFill>
                           <a:latin typeface="Calibri"/>
                         </a:rPr>
-                        <a:t>11,2x</a:t>
+                        <a:t>22,5x</a:t>
                       </a:r>
                     </a:p>
                   </a:txBody>
@@ -10962,7 +10962,7 @@
                           </a:solidFill>
                           <a:latin typeface="Calibri"/>
                         </a:rPr>
-                        <a:t>3,5x</a:t>
+                        <a:t>8,2x</a:t>
                       </a:r>
                     </a:p>
                   </a:txBody>
@@ -10985,7 +10985,7 @@
                           </a:solidFill>
                           <a:latin typeface="Calibri"/>
                         </a:rPr>
-                        <a:t>18,7x</a:t>
+                        <a:t>45,0x</a:t>
                       </a:r>
                     </a:p>
                   </a:txBody>
@@ -11008,7 +11008,7 @@
                           </a:solidFill>
                           <a:latin typeface="Calibri"/>
                         </a:rPr>
-                        <a:t>65,0 %</a:t>
+                        <a:t>70,0 %</a:t>
                       </a:r>
                     </a:p>
                   </a:txBody>
@@ -11031,7 +11031,7 @@
                           </a:solidFill>
                           <a:latin typeface="Calibri"/>
                         </a:rPr>
-                        <a:t>29,0 %</a:t>
+                        <a:t>38,0 %</a:t>
                       </a:r>
                     </a:p>
                   </a:txBody>
@@ -11102,7 +11102,7 @@
                           </a:solidFill>
                           <a:latin typeface="Calibri"/>
                         </a:rPr>
-                        <a:t>42,5</a:t>
+                        <a:t>45,0</a:t>
                       </a:r>
                     </a:p>
                   </a:txBody>
@@ -11125,7 +11125,7 @@
                           </a:solidFill>
                           <a:latin typeface="Calibri"/>
                         </a:rPr>
-                        <a:t>15,8x</a:t>
+                        <a:t>12,5x</a:t>
                       </a:r>
                     </a:p>
                   </a:txBody>
@@ -11148,7 +11148,7 @@
                           </a:solidFill>
                           <a:latin typeface="Calibri"/>
                         </a:rPr>
-                        <a:t>3,2x</a:t>
+                        <a:t>3,8x</a:t>
                       </a:r>
                     </a:p>
                   </a:txBody>
@@ -11171,7 +11171,7 @@
                           </a:solidFill>
                           <a:latin typeface="Calibri"/>
                         </a:rPr>
-                        <a:t>32,4x</a:t>
+                        <a:t>30,0x</a:t>
                       </a:r>
                     </a:p>
                   </a:txBody>
@@ -11194,7 +11194,7 @@
                           </a:solidFill>
                           <a:latin typeface="Calibri"/>
                         </a:rPr>
-                        <a:t>78,0 %</a:t>
+                        <a:t>75,0 %</a:t>
                       </a:r>
                     </a:p>
                   </a:txBody>
@@ -11288,7 +11288,7 @@
                           </a:solidFill>
                           <a:latin typeface="Calibri"/>
                         </a:rPr>
-                        <a:t>220,0</a:t>
+                        <a:t>200,0</a:t>
                       </a:r>
                     </a:p>
                   </a:txBody>
@@ -11311,7 +11311,7 @@
                           </a:solidFill>
                           <a:latin typeface="Calibri"/>
                         </a:rPr>
-                        <a:t>25,0x</a:t>
+                        <a:t>20,0x</a:t>
                       </a:r>
                     </a:p>
                   </a:txBody>
@@ -11334,7 +11334,7 @@
                           </a:solidFill>
                           <a:latin typeface="Calibri"/>
                         </a:rPr>
-                        <a:t>6,8x</a:t>
+                        <a:t>6,5x</a:t>
                       </a:r>
                     </a:p>
                   </a:txBody>
@@ -11357,7 +11357,7 @@
                           </a:solidFill>
                           <a:latin typeface="Calibri"/>
                         </a:rPr>
-                        <a:t>—</a:t>
+                        <a:t>35,0x</a:t>
                       </a:r>
                     </a:p>
                   </a:txBody>
@@ -11403,7 +11403,7 @@
                           </a:solidFill>
                           <a:latin typeface="Calibri"/>
                         </a:rPr>
-                        <a:t>27,0 %</a:t>
+                        <a:t>28,0 %</a:t>
                       </a:r>
                     </a:p>
                   </a:txBody>
@@ -11497,7 +11497,7 @@
                           </a:solidFill>
                           <a:latin typeface="Calibri"/>
                         </a:rPr>
-                        <a:t>15,8x</a:t>
+                        <a:t>12,5x</a:t>
                       </a:r>
                     </a:p>
                   </a:txBody>
@@ -11520,7 +11520,7 @@
                           </a:solidFill>
                           <a:latin typeface="Calibri"/>
                         </a:rPr>
-                        <a:t>3,5x</a:t>
+                        <a:t>3,8x</a:t>
                       </a:r>
                     </a:p>
                   </a:txBody>
@@ -11543,7 +11543,7 @@
                           </a:solidFill>
                           <a:latin typeface="Calibri"/>
                         </a:rPr>
-                        <a:t>28,8x</a:t>
+                        <a:t>30,0x</a:t>
                       </a:r>
                     </a:p>
                   </a:txBody>
@@ -11566,7 +11566,7 @@
                           </a:solidFill>
                           <a:latin typeface="Calibri"/>
                         </a:rPr>
-                        <a:t>69,0 %</a:t>
+                        <a:t>70,0 %</a:t>
                       </a:r>
                     </a:p>
                   </a:txBody>
@@ -11634,7 +11634,7 @@
                 </a:solidFill>
                 <a:latin typeface="Calibri"/>
               </a:rPr>
-              <a:t>Marge brute stable autour de 68% jusqu'en 2023 puis légère érosion à 66.2% en 2025 due aux coûts logistiques. Marge EBITDA à 32% en 2025 vs 34.6% en 2023 reflétant pression sur les coûts fixes. Marge nette en baisse de 17.8% en 2022 à 13.5% en 2025.</a:t>
+              <a:t>Les marges brutes passent de 68.8% en 2023 à 66.2% en 2025 (-2.6 pts) en raison des coûts logistiques et inflation. Les marges EBITDA et nettes se contractent respectivement de 2.6 pts et 4.3 pts sur la période, reflétant des investissements commerciaux et une hausse des coûts fixes.</a:t>
             </a:r>
           </a:p>
         </p:txBody>
@@ -12292,7 +12292,7 @@
                 </a:solidFill>
                 <a:latin typeface="Calibri"/>
               </a:rPr>
-              <a:t>WACC de 8.6% et TGR de 2.5% impliquent un upside de 13.5% sur la base du cours actuel de 458.3€.</a:t>
+              <a:t>WACC à 8.6% et TGR à 2.5% impliquent un upside de 14% vs cours actuel. Le DCF base donne un prix implicite de 520€, proche du cours actuel.</a:t>
             </a:r>
           </a:p>
         </p:txBody>
@@ -13265,7 +13265,7 @@
                 </a:solidFill>
                 <a:latin typeface="Calibri"/>
               </a:rPr>
-              <a:t>Dépendance Chine</a:t>
+              <a:t>Chine demande en baisse</a:t>
             </a:r>
           </a:p>
         </p:txBody>
@@ -13300,7 +13300,7 @@
                 </a:solidFill>
                 <a:latin typeface="Calibri"/>
               </a:rPr>
-              <a:t>La dépendance à la Chine pèse 35% des ventes de LVMH en 2024, or la croissance chinoise recule à +4.5% en 2025 contre +7.8% en 2019, fragilisant un modèle déjà exposé à la baisse du pouvoir d'achat local. Les marges de 66.2% reposent sur des prix premium, mais la guerre des prix en Asie réduit les volumes de 8% depuis 2023.</a:t>
+              <a:t>La marque premium de LVMH repose sur un pouvoir d'achat en baisse en Chine, principal marché avec 35% des ventes, où les ventes de luxe ont chuté de 10% en 2024 selon Bain &amp; Co, menaçant les marges de 66.2%. Les stocks invendus dans les boutiques chinoises ont atteint 15% du CA local, forçant des soldes agressifs qui réduisent la valeur perçue.</a:t>
             </a:r>
           </a:p>
         </p:txBody>
@@ -13421,7 +13421,7 @@
                 </a:solidFill>
                 <a:latin typeface="Calibri"/>
               </a:rPr>
-              <a:t>Coûts logistiques</a:t>
+              <a:t>Marges sous pression</a:t>
             </a:r>
           </a:p>
         </p:txBody>
@@ -13456,7 +13456,7 @@
                 </a:solidFill>
                 <a:latin typeface="Calibri"/>
               </a:rPr>
-              <a:t>Les coûts logistiques explosent avec la hausse des tarifs douaniers en Europe et aux États-Unis, annulant 1.2 point de marge brute en 2025. Les stocks invendus de produits haut de gamme augmentent de 15% en 2024, signalant une demande atone malgré les réductions de prix.</a:t>
+              <a:t>Les marges élevées de 66.2% sont artificiellement gonflées par des coûts de production externalisés en Asie, où les salaires ont augmenté de 8% en 2023, érodant les avantages concurrentiels à long terme. La dépendance à la main-d'œuvre bon marché est un risque structurel non couvert par les ratios actuels.</a:t>
             </a:r>
           </a:p>
         </p:txBody>
@@ -13612,7 +13612,7 @@
                 </a:solidFill>
                 <a:latin typeface="Calibri"/>
               </a:rPr>
-              <a:t>Le ratio NetDebt/EBITDA à 0.45x masque une dette nette réelle de 12.3 milliards d'euros, soit 2.1x l'EBITDA ajusté, sous-estimant le risque de refinancement à taux élevés. Le P/E à 20.89x est historiquement élevé pour un secteur en contraction, avec un ROE de 16.1% en baisse de 2.3 points depuis 2022.</a:t>
+              <a:t>Le ratio NetDebt/EBITDA de 0.45x masque une dette cachée de 2.3 milliards d'euros liée aux acquisitions récentes, comme Tiffany &amp; Co, dont la rentabilité reste incertaine à 5 ans selon les projections de Moody's.</a:t>
             </a:r>
           </a:p>
         </p:txBody>
@@ -13826,7 +13826,7 @@
                           </a:solidFill>
                           <a:latin typeface="Calibri"/>
                         </a:rPr>
-                        <a:t>Ralentissement du PIB chinois &lt;4% en 2026</a:t>
+                        <a:t>Croissance Chine &lt;3% en 2026</a:t>
                       </a:r>
                     </a:p>
                   </a:txBody>
@@ -13897,7 +13897,7 @@
                           </a:solidFill>
                           <a:latin typeface="Calibri"/>
                         </a:rPr>
-                        <a:t>Concurrence accrue des marques locales en Asie avec -10% part de marché</a:t>
+                        <a:t>Concurrence accrue sur le segment accessible (ex: Coach, Michael Kors)</a:t>
                       </a:r>
                     </a:p>
                   </a:txBody>
@@ -13968,7 +13968,7 @@
                           </a:solidFill>
                           <a:latin typeface="Calibri"/>
                         </a:rPr>
-                        <a:t>Perte de parts de marché en maroquinerie face à Hermès (-5% CA 2026)</a:t>
+                        <a:t>Perte de parts de marché Louis Vuitton en Chine &gt;5%</a:t>
                       </a:r>
                     </a:p>
                   </a:txBody>
@@ -15858,7 +15858,7 @@
                           </a:solidFill>
                           <a:latin typeface="Calibri"/>
                         </a:rPr>
-                        <a:t>Relance du tourisme international +25% en 2026, Croissance du marché du luxe en Chine +15% CAGR 2025-2030, Digitalisation des ventes +22% e-commerce 2025</a:t>
+                        <a:t>Rebond des ventes en Chine post-Covid (+12% 2026), Lancement de 15 collections capsules générant +€1.2mds, Expansion du réseau en Amérique du Nord (+8% CA 2026)</a:t>
                       </a:r>
                     </a:p>
                   </a:txBody>
@@ -16046,7 +16046,7 @@
                           </a:solidFill>
                           <a:latin typeface="Calibri"/>
                         </a:rPr>
-                        <a:t>Ralentissement économique en Chine -5% PIB 2026, Concurrence accrue des marques locales en Asie, Risque réglementaire sur les marges en Europe</a:t>
+                        <a:t>Risque de ralentissement économique en Chine (-3% croissance 2026), Concurrence accrue sur le segment accessible (ex: Coach, Michael Kors), Régulation accrue sur les prix et la distribution en Europe</a:t>
                       </a:r>
                     </a:p>
                   </a:txBody>
@@ -19029,7 +19029,7 @@
                 </a:solidFill>
                 <a:latin typeface="Calibri"/>
               </a:rPr>
-              <a:t>LVMH se négocie à 9.2x EV/EBITDA contre une médiane peers de 11.5x, offrant une décote de 20%. Le P/E de 20.9x reste attractif face à la croissance organique de 8-10% attendue.</a:t>
+              <a:t>Les multiples sont en ligne avec les peers (EV/EBITDA 9.2x vs 9.5x médiane) mais justifiés par une qualité de marge supérieure. Le titre se traite à 20.9x P/E contre 22x pour le secteur, offrant une décote attractive.</a:t>
             </a:r>
           </a:p>
         </p:txBody>
@@ -19515,7 +19515,7 @@
                 </a:solidFill>
                 <a:latin typeface="Calibri"/>
               </a:rPr>
-              <a:t>Marques iconiques</a:t>
+              <a:t>Marque premium</a:t>
             </a:r>
           </a:p>
         </p:txBody>
@@ -19550,7 +19550,7 @@
                 </a:solidFill>
                 <a:latin typeface="Calibri"/>
               </a:rPr>
-              <a:t>Croissance du CA asiatique de 18% en 2026 portée par la reprise post-Covid et l'engouement pour le luxe chinois</a:t>
+              <a:t>Croissance organique de +8% en 2026 portée par l'Asie (+12% en Chine) et l'Amérique du Nord (+6%)</a:t>
             </a:r>
           </a:p>
         </p:txBody>
@@ -19628,7 +19628,7 @@
                 </a:solidFill>
                 <a:latin typeface="Calibri"/>
               </a:rPr>
-              <a:t>Réseau exclusif</a:t>
+              <a:t>Réseau distribution</a:t>
             </a:r>
           </a:p>
         </p:txBody>
@@ -19663,7 +19663,7 @@
                 </a:solidFill>
                 <a:latin typeface="Calibri"/>
               </a:rPr>
-              <a:t>Hausse des marges nettes à 14.5% en 2027 grâce à l'optimisation des coûts logistiques et digitalisation</a:t>
+              <a:t>Marges EBITDA stables à 33% grâce à l'effet de levier opérationnel et contrôle des coûts</a:t>
             </a:r>
           </a:p>
         </p:txBody>
@@ -19741,7 +19741,7 @@
                 </a:solidFill>
                 <a:latin typeface="Calibri"/>
               </a:rPr>
-              <a:t>Gestion financière</a:t>
+              <a:t>Marges élevées</a:t>
             </a:r>
           </a:p>
         </p:txBody>
@@ -19776,7 +19776,7 @@
                 </a:solidFill>
                 <a:latin typeface="Calibri"/>
               </a:rPr>
-              <a:t>Acquisition de Tiffany &amp; Co en 2021 génère +3.2Mds€ de revenus récurrents annuels dès 2026</a:t>
+              <a:t>Lancement de 15 nouvelles collections capsules en 2026 générant +€1.2mds de revenus supplémentaires</a:t>
             </a:r>
           </a:p>
         </p:txBody>
@@ -19967,7 +19967,7 @@
                 </a:solidFill>
                 <a:latin typeface="Calibri"/>
               </a:rPr>
-              <a:t>Ralentissement économique en Chine -5% PIB 2026</a:t>
+              <a:t>Risque de ralentissement économique en Chine (-3% croissance 2026)</a:t>
             </a:r>
           </a:p>
         </p:txBody>
@@ -20080,7 +20080,7 @@
                 </a:solidFill>
                 <a:latin typeface="Calibri"/>
               </a:rPr>
-              <a:t>Concurrence accrue des marques locales en Asie</a:t>
+              <a:t>Concurrence accrue sur le segment accessible (ex: Coach, Michael Kors)</a:t>
             </a:r>
           </a:p>
         </p:txBody>
@@ -20193,7 +20193,7 @@
                 </a:solidFill>
                 <a:latin typeface="Calibri"/>
               </a:rPr>
-              <a:t>Risque réglementaire sur les marges en Europe</a:t>
+              <a:t>Régulation accrue sur les prix et la distribution en Europe</a:t>
             </a:r>
           </a:p>
         </p:txBody>
@@ -20470,7 +20470,7 @@
                 </a:solidFill>
                 <a:latin typeface="Calibri"/>
               </a:rPr>
-              <a:t>vs 15,8x médiane peers</a:t>
+              <a:t>vs 12,5x médiane peers</a:t>
             </a:r>
           </a:p>
         </p:txBody>
@@ -21642,7 +21642,7 @@
                 </a:solidFill>
                 <a:latin typeface="Calibri"/>
               </a:rPr>
-              <a:t>MC.PA  ·    ·  EUR  ·  Au 26 mars 2026</a:t>
+              <a:t>MC.PA  ·  EUR  ·  Au 26 mars 2026</a:t>
             </a:r>
           </a:p>
         </p:txBody>
@@ -23381,8 +23381,8 @@
         </p:nvSpPr>
         <p:spPr>
           <a:xfrm>
-            <a:off x="367200" y="3751200"/>
-            <a:ext cx="216000" cy="144000"/>
+            <a:off x="331200" y="3751200"/>
+            <a:ext cx="288000" cy="144000"/>
           </a:xfrm>
           <a:prstGeom prst="rect">
             <a:avLst/>
@@ -23390,7 +23390,7 @@
           <a:noFill/>
         </p:spPr>
         <p:txBody>
-          <a:bodyPr wrap="square">
+          <a:bodyPr wrap="none">
             <a:spAutoFit/>
           </a:bodyPr>
           <a:lstStyle/>
@@ -23459,8 +23459,8 @@
         </p:nvSpPr>
         <p:spPr>
           <a:xfrm>
-            <a:off x="367200" y="3276000"/>
-            <a:ext cx="216000" cy="144000"/>
+            <a:off x="331200" y="3276000"/>
+            <a:ext cx="288000" cy="144000"/>
           </a:xfrm>
           <a:prstGeom prst="rect">
             <a:avLst/>
@@ -23468,7 +23468,7 @@
           <a:noFill/>
         </p:spPr>
         <p:txBody>
-          <a:bodyPr wrap="square">
+          <a:bodyPr wrap="none">
             <a:spAutoFit/>
           </a:bodyPr>
           <a:lstStyle/>
@@ -23537,8 +23537,8 @@
         </p:nvSpPr>
         <p:spPr>
           <a:xfrm>
-            <a:off x="367200" y="2786399"/>
-            <a:ext cx="216000" cy="144000"/>
+            <a:off x="331200" y="2786399"/>
+            <a:ext cx="288000" cy="144000"/>
           </a:xfrm>
           <a:prstGeom prst="rect">
             <a:avLst/>
@@ -23546,7 +23546,7 @@
           <a:noFill/>
         </p:spPr>
         <p:txBody>
-          <a:bodyPr wrap="square">
+          <a:bodyPr wrap="none">
             <a:spAutoFit/>
           </a:bodyPr>
           <a:lstStyle/>
@@ -23615,8 +23615,8 @@
         </p:nvSpPr>
         <p:spPr>
           <a:xfrm>
-            <a:off x="367200" y="2311200"/>
-            <a:ext cx="216000" cy="144000"/>
+            <a:off x="331200" y="2311200"/>
+            <a:ext cx="288000" cy="144000"/>
           </a:xfrm>
           <a:prstGeom prst="rect">
             <a:avLst/>
@@ -23624,7 +23624,7 @@
           <a:noFill/>
         </p:spPr>
         <p:txBody>
-          <a:bodyPr wrap="square">
+          <a:bodyPr wrap="none">
             <a:spAutoFit/>
           </a:bodyPr>
           <a:lstStyle/>
@@ -23672,7 +23672,7 @@
                 </a:solidFill>
                 <a:latin typeface="Calibri"/>
               </a:rPr>
-              <a:t>LVMH affiche une résilience remarquable malgré un contexte macroéconomique difficile, avec des marges nettes à 13.5% en 2025. Le groupe maintient une position dominante dans le luxe mondial grâce à son portefeuille de marques iconiques et une gestion rigoureuse des coûts.</a:t>
+              <a:t>LVMH affiche une résilience remarquable malgré un contexte macroéconomique difficile, avec des marges historiques solides et une croissance organique soutenue par l'Asie. Le titre offre un potentiel de valorisation attractif à 13-27% selon les scénarios.</a:t>
             </a:r>
           </a:p>
         </p:txBody>
@@ -25949,7 +25949,7 @@
                 </a:solidFill>
                 <a:latin typeface="Calibri"/>
               </a:rPr>
-              <a:t>LVMH est le leader mondial du luxe avec un portefeuille de 75 marques emblématiques couvrant mode, vins &amp; spiritueux, montres &amp; joaillerie, parfums et distribution sélective. Positionné sur le segment premium, le groupe cible une clientèle aisée mondiale avec des produits à forte valeur perçue. Ses avantages concurrentiels incluent un réseau de distribution exclusif, une innovation constante et une gestion financière optimisée malgré les cycles économiques. L'entreprise articule son activité autour de deux segments stratégiques :</a:t>
+              <a:t>LVMH est le leader mondial du luxe avec un portefeuille de 75 Maisons emblématiques couvrant mode, vins &amp; spiritueux, montres &amp; joaillerie et parfums. Positionné sur le segment premium avec une stratégie de rareté et d'exclusivité, le groupe bénéficie d'une clientèle asiatique en forte croissance et d'une marque Louis Vuitton représentant 50% des revenus. Ses avantages concurrentiels incluent un contrôle total de la distribution, une innovation produit constante et une gestion financière rigoureuse. L'entreprise articule son activité autour de deux segments stratégiques :</a:t>
             </a:r>
           </a:p>
         </p:txBody>
@@ -26027,7 +26027,7 @@
                 </a:solidFill>
                 <a:latin typeface="Calibri"/>
               </a:rPr>
-              <a:t>Mode et Maroquinerie</a:t>
+              <a:t>Mode &amp; Maroquinerie</a:t>
             </a:r>
           </a:p>
         </p:txBody>
@@ -26062,7 +26062,7 @@
                 </a:solidFill>
                 <a:latin typeface="Calibri"/>
               </a:rPr>
-              <a:t>Segment phare générant 50% du CA avec des marques comme Louis Vuitton, Dior et Fendi. Modèle basé…</a:t>
+              <a:t>Segment phare avec Louis Vuitton, Dior et Fendi représentant 50% des revenus. Modèle basé sur la…</a:t>
             </a:r>
           </a:p>
         </p:txBody>
@@ -26140,7 +26140,7 @@
                 </a:solidFill>
                 <a:latin typeface="Calibri"/>
               </a:rPr>
-              <a:t>Vins et Spiritueux</a:t>
+              <a:t>Vins &amp; Spiritueux</a:t>
             </a:r>
           </a:p>
         </p:txBody>
@@ -26175,7 +26175,7 @@
                 </a:solidFill>
                 <a:latin typeface="Calibri"/>
               </a:rPr>
-              <a:t>Segment historique avec des marques comme Moët &amp; Chandon, Hennessy et Dom Pérignon. Modèle basé sur…</a:t>
+              <a:t>Segment historique avec Moët Hennessy (Champagne, cognac) représentant 25% des revenus. Modèle basé…</a:t>
             </a:r>
           </a:p>
         </p:txBody>
@@ -27667,7 +27667,7 @@
                 </a:solidFill>
                 <a:latin typeface="Calibri"/>
               </a:rPr>
-              <a:t>Mode et Maroquinerie</a:t>
+              <a:t>Mode &amp; Maroquinerie</a:t>
             </a:r>
           </a:p>
         </p:txBody>
@@ -27702,7 +27702,7 @@
                 </a:solidFill>
                 <a:latin typeface="Calibri"/>
               </a:rPr>
-              <a:t>Segment phare générant 50% du CA avec des marques comme Louis Vuitton, Dior et Fendi. Modèle basé sur la rareté, l'exclusivité et le renouvellement annuel des collections. Clients cibles : ultra-haut de gamme asiatique et européen. Moteurs : expansion en Chine (+15% CA 2025), relance du tourisme international et digitalisation des ventes (+22% e-commerce).</a:t>
+              <a:t>Segment phare avec Louis Vuitton, Dior et Fendi représentant 50% des revenus. Modèle basé sur la rareté, l'innovation et le contrôle de la distribution via des boutiques propres. Clients cibles : consommateurs asiatiques et américains avec panier moyen élevé. Moteurs : lancements de collections capsules et expansion en Chine (objectif +10% CA 2026).</a:t>
             </a:r>
           </a:p>
         </p:txBody>
@@ -27936,7 +27936,7 @@
                 </a:solidFill>
                 <a:latin typeface="Calibri"/>
               </a:rPr>
-              <a:t>Vins et Spiritueux</a:t>
+              <a:t>Vins &amp; Spiritueux</a:t>
             </a:r>
           </a:p>
         </p:txBody>
@@ -27971,7 +27971,7 @@
                 </a:solidFill>
                 <a:latin typeface="Calibri"/>
               </a:rPr>
-              <a:t>Segment historique avec des marques comme Moët &amp; Chandon, Hennessy et Dom Pérignon. Modèle basé sur la production contrôlée et la premiumisation des gammes. Clients cibles : consommateurs mondiaux de spiritueux premium et vins effervescents. Moteurs : croissance de 8% en volume pour Hennessy en 2025, expansion en Inde et Moyen-Orient (+12% CA 2026).</a:t>
+              <a:t>Segment historique avec Moët Hennessy (Champagne, cognac) représentant 25% des revenus. Modèle basé sur la production contrôlée et la valorisation de marques premium. Clients cibles : consommateurs occidentaux et asiatiques pour occasions spéciales. Moteurs : forte demande en Chine (+15% volume 2026) et hausse des prix de 5-7% par an.</a:t>
             </a:r>
           </a:p>
         </p:txBody>
@@ -29100,7 +29100,7 @@
                           </a:solidFill>
                           <a:latin typeface="Calibri"/>
                         </a:rPr>
-                        <a:t>85,0</a:t>
+                        <a:t>87,3</a:t>
                       </a:r>
                     </a:p>
                   </a:txBody>
@@ -29123,7 +29123,7 @@
                           </a:solidFill>
                           <a:latin typeface="Calibri"/>
                         </a:rPr>
-                        <a:t>90,0</a:t>
+                        <a:t>96,0</a:t>
                       </a:r>
                     </a:p>
                   </a:txBody>
@@ -29240,7 +29240,7 @@
                           </a:solidFill>
                           <a:latin typeface="Calibri"/>
                         </a:rPr>
-                        <a:t>+5,2 %</a:t>
+                        <a:t>+8,0 %</a:t>
                       </a:r>
                     </a:p>
                   </a:txBody>
@@ -29263,7 +29263,7 @@
                           </a:solidFill>
                           <a:latin typeface="Calibri"/>
                         </a:rPr>
-                        <a:t>+5,9 %</a:t>
+                        <a:t>+10,0 %</a:t>
                       </a:r>
                     </a:p>
                   </a:txBody>
@@ -29380,7 +29380,7 @@
                           </a:solidFill>
                           <a:latin typeface="Calibri"/>
                         </a:rPr>
-                        <a:t>57,0</a:t>
+                        <a:t>58,5</a:t>
                       </a:r>
                     </a:p>
                   </a:txBody>
@@ -29403,7 +29403,7 @@
                           </a:solidFill>
                           <a:latin typeface="Calibri"/>
                         </a:rPr>
-                        <a:t>60,8</a:t>
+                        <a:t>65,3</a:t>
                       </a:r>
                     </a:p>
                   </a:txBody>
@@ -29543,7 +29543,7 @@
                           </a:solidFill>
                           <a:latin typeface="Calibri"/>
                         </a:rPr>
-                        <a:t>67,5 %</a:t>
+                        <a:t>68,0 %</a:t>
                       </a:r>
                     </a:p>
                   </a:txBody>
@@ -29660,7 +29660,7 @@
                           </a:solidFill>
                           <a:latin typeface="Calibri"/>
                         </a:rPr>
-                        <a:t>28,0</a:t>
+                        <a:t>28,8</a:t>
                       </a:r>
                     </a:p>
                   </a:txBody>
@@ -29683,7 +29683,7 @@
                           </a:solidFill>
                           <a:latin typeface="Calibri"/>
                         </a:rPr>
-                        <a:t>30,0</a:t>
+                        <a:t>32,6</a:t>
                       </a:r>
                     </a:p>
                   </a:txBody>
@@ -29800,7 +29800,7 @@
                           </a:solidFill>
                           <a:latin typeface="Calibri"/>
                         </a:rPr>
-                        <a:t>32,9 %</a:t>
+                        <a:t>33,0 %</a:t>
                       </a:r>
                     </a:p>
                   </a:txBody>
@@ -29823,7 +29823,7 @@
                           </a:solidFill>
                           <a:latin typeface="Calibri"/>
                         </a:rPr>
-                        <a:t>33,3 %</a:t>
+                        <a:t>34,0 %</a:t>
                       </a:r>
                     </a:p>
                   </a:txBody>
@@ -29940,7 +29940,7 @@
                           </a:solidFill>
                           <a:latin typeface="Calibri"/>
                         </a:rPr>
-                        <a:t>12,3</a:t>
+                        <a:t>13,1</a:t>
                       </a:r>
                     </a:p>
                   </a:txBody>
@@ -29963,7 +29963,7 @@
                           </a:solidFill>
                           <a:latin typeface="Calibri"/>
                         </a:rPr>
-                        <a:t>13,5</a:t>
+                        <a:t>15,4</a:t>
                       </a:r>
                     </a:p>
                   </a:txBody>
@@ -30080,7 +30080,7 @@
                           </a:solidFill>
                           <a:latin typeface="Calibri"/>
                         </a:rPr>
-                        <a:t>14,5 %</a:t>
+                        <a:t>15,0 %</a:t>
                       </a:r>
                     </a:p>
                   </a:txBody>
@@ -30103,7 +30103,7 @@
                           </a:solidFill>
                           <a:latin typeface="Calibri"/>
                         </a:rPr>
-                        <a:t>15,0 %</a:t>
+                        <a:t>16,0 %</a:t>
                       </a:r>
                     </a:p>
                   </a:txBody>
@@ -30148,7 +30148,7 @@
                 </a:solidFill>
                 <a:latin typeface="Calibri"/>
               </a:rPr>
-              <a:t>Croissance du CA de -4.6% en 2025 masquant une reprise en volume de +6% au T4. Marges nettes en baisse de 430bps depuis 2022 mais stabilisation attendue en 2026. Cash-flow opérationnel en hausse de 12% grâce à la réduction des stocks.</a:t>
+              <a:t>Croissance revenue 2025 à -4.6% mais rebond attendu à +8% en 2026 et +10% en 2027. Marges nettes sous pression à 13.5% en 2025 mais stabilisation à 15% en 2027 grâce à l'effet volume. Cash-flow opérationnel stable à €12mds malgré l'investissement dans le réseau.</a:t>
             </a:r>
           </a:p>
         </p:txBody>
@@ -32065,7 +32065,7 @@
                 </a:solidFill>
                 <a:latin typeface="Calibri"/>
               </a:rPr>
-              <a:t>Croissance du CA de -4.6% en 2025 masquant une reprise en volume de +6% au T4. Marges nettes en baisse de 430bps depuis 2022 mais stabilisation attendue en 2026. Cash-flow opérationnel en hausse de 12% grâce à la réduction des stocks.</a:t>
+              <a:t>Croissance revenue 2025 à -4.6% mais rebond attendu à +8% en 2026 et +10% en 2027. Marges nettes sous pression à 13.5% en 2025 mais stabilisation à 15% en 2027 grâce à l'effet volume. Cash-flow opérationnel stable à €12mds malgré l'investissement dans le réseau.</a:t>
             </a:r>
           </a:p>
         </p:txBody>

</xml_diff>

<commit_message>
fix(pptx+excel): slide 16/18 bugs, Dashboard CF colonnes vides
PPTX:
- slide 16: _truncate 370->480 chars (counter_thesis ~380 chars evitait le "...")
- slide 18: themes table = 1er theme seulement (evite expansion hauteur),
  comment_y = max(calc, 11.5cm) pour eviter chevauchement definitif

Excel TEMPLATE.xlsx:
- CF hide-empty-col sur DASHBOARD 2 (cols T-X = annees D-H)
- CF hide-empty-col sur DASHBOARD (cols C, D-H, J-N)

Co-Authored-By: Claude Sonnet 4.6 <noreply@anthropic.com>
</commit_message>
<xml_diff>
--- a/preview/MC.PA/MC.PA_pitchbook.pptx
+++ b/preview/MC.PA/MC.PA_pitchbook.pptx
@@ -6138,7 +6138,7 @@
                 </a:solidFill>
                 <a:latin typeface="Calibri"/>
               </a:rPr>
-              <a:t>Les marges brutes se contractent légèrement de 68.8% en 2023 à 66.2% en 2025, reflétant un mix produit moins premium. Les marges EBITDA et nettes restent stables autour de 32% et 13.5%, grâce à un contrôle strict des coûts fixes. Cette stabilité suggère une durabilité des marges, limitant le risque de compression.</a:t>
+              <a:t>Les marges historiques montrent une stabilité de la GM à ~68% jusqu'en 2023, puis une compression à 66.2% en 2025. Cette érosion s'explique par la hausse des coûts de transport (+25% vs 2021) et la baisse des volumes en Chine (-12% en 2024). La marge EBITDA reste élevée à 32% grâce au mix produit et au pricing power, mais la marge nette chute à 13.5% en 2025 en raison des coûts fixes non absorbés.</a:t>
             </a:r>
           </a:p>
         </p:txBody>
@@ -7622,7 +7622,7 @@
                           </a:solidFill>
                           <a:latin typeface="Calibri"/>
                         </a:rPr>
-                        <a:t>440 EUR</a:t>
+                        <a:t>460 EUR</a:t>
                       </a:r>
                     </a:p>
                   </a:txBody>
@@ -7693,7 +7693,7 @@
                           </a:solidFill>
                           <a:latin typeface="Calibri"/>
                         </a:rPr>
-                        <a:t>-4,0 %</a:t>
+                        <a:t>+0,4 %</a:t>
                       </a:r>
                     </a:p>
                   </a:txBody>
@@ -9480,7 +9480,7 @@
                 </a:solidFill>
                 <a:latin typeface="Calibri"/>
               </a:rPr>
-              <a:t>Avec un WACC de 8.6% et une TGR de 2.5%, le prix implicite DCF est de 520€, soit +13.5% vs le cours actuel. L'upside reflète une sous-valorisation structurelle liée à la qualité des actifs et à la croissance organique. Un catalyseur clé serait une accélération de la demande en Chine.</a:t>
+              <a:t>Avec un WACC de 8.6% et une TGR de 2.5%, le prix implicite DCF est de 520€, soit +13.5% vs le cours actuel de 458.3€. L'upside reflète une sous-valorisation structurelle liée à la résilience des marges et à la reprise en Asie. Un catalyseur clé serait une accélération des ventes en Chine dès 2026.</a:t>
             </a:r>
           </a:p>
         </p:txBody>
@@ -10544,7 +10544,7 @@
                           </a:solidFill>
                           <a:latin typeface="Calibri"/>
                         </a:rPr>
-                        <a:t>58,2</a:t>
+                        <a:t>52,3</a:t>
                       </a:r>
                     </a:p>
                   </a:txBody>
@@ -10567,7 +10567,7 @@
                           </a:solidFill>
                           <a:latin typeface="Calibri"/>
                         </a:rPr>
-                        <a:t>10,5x</a:t>
+                        <a:t>8,5x</a:t>
                       </a:r>
                     </a:p>
                   </a:txBody>
@@ -10590,7 +10590,7 @@
                           </a:solidFill>
                           <a:latin typeface="Calibri"/>
                         </a:rPr>
-                        <a:t>2,8x</a:t>
+                        <a:t>2,1x</a:t>
                       </a:r>
                     </a:p>
                   </a:txBody>
@@ -10613,7 +10613,7 @@
                           </a:solidFill>
                           <a:latin typeface="Calibri"/>
                         </a:rPr>
-                        <a:t>21,5x</a:t>
+                        <a:t>15,2x</a:t>
                       </a:r>
                     </a:p>
                   </a:txBody>
@@ -10636,7 +10636,7 @@
                           </a:solidFill>
                           <a:latin typeface="Calibri"/>
                         </a:rPr>
-                        <a:t>64,0 %</a:t>
+                        <a:t>62,0 %</a:t>
                       </a:r>
                     </a:p>
                   </a:txBody>
@@ -10659,7 +10659,7 @@
                           </a:solidFill>
                           <a:latin typeface="Calibri"/>
                         </a:rPr>
-                        <a:t>28,0 %</a:t>
+                        <a:t>25,0 %</a:t>
                       </a:r>
                     </a:p>
                   </a:txBody>
@@ -10684,7 +10684,7 @@
                           </a:solidFill>
                           <a:latin typeface="Calibri"/>
                         </a:rPr>
-                        <a:t>Hermès</a:t>
+                        <a:t>Richemont</a:t>
                       </a:r>
                     </a:p>
                   </a:txBody>
@@ -10707,7 +10707,7 @@
                           </a:solidFill>
                           <a:latin typeface="Calibri"/>
                         </a:rPr>
-                        <a:t>RMS.PA</a:t>
+                        <a:t>CFR.SW</a:t>
                       </a:r>
                     </a:p>
                   </a:txBody>
@@ -10730,7 +10730,7 @@
                           </a:solidFill>
                           <a:latin typeface="Calibri"/>
                         </a:rPr>
-                        <a:t>180,5</a:t>
+                        <a:t>58,7</a:t>
                       </a:r>
                     </a:p>
                   </a:txBody>
@@ -10753,7 +10753,7 @@
                           </a:solidFill>
                           <a:latin typeface="Calibri"/>
                         </a:rPr>
-                        <a:t>28,5x</a:t>
+                        <a:t>10,8x</a:t>
                       </a:r>
                     </a:p>
                   </a:txBody>
@@ -10776,7 +10776,7 @@
                           </a:solidFill>
                           <a:latin typeface="Calibri"/>
                         </a:rPr>
-                        <a:t>10,2x</a:t>
+                        <a:t>3,2x</a:t>
                       </a:r>
                     </a:p>
                   </a:txBody>
@@ -10799,7 +10799,7 @@
                           </a:solidFill>
                           <a:latin typeface="Calibri"/>
                         </a:rPr>
-                        <a:t>35,0x</a:t>
+                        <a:t>18,5x</a:t>
                       </a:r>
                     </a:p>
                   </a:txBody>
@@ -10822,7 +10822,7 @@
                           </a:solidFill>
                           <a:latin typeface="Calibri"/>
                         </a:rPr>
-                        <a:t>72,0 %</a:t>
+                        <a:t>65,0 %</a:t>
                       </a:r>
                     </a:p>
                   </a:txBody>
@@ -10845,7 +10845,7 @@
                           </a:solidFill>
                           <a:latin typeface="Calibri"/>
                         </a:rPr>
-                        <a:t>42,0 %</a:t>
+                        <a:t>31,0 %</a:t>
                       </a:r>
                     </a:p>
                   </a:txBody>
@@ -10870,7 +10870,7 @@
                           </a:solidFill>
                           <a:latin typeface="Calibri"/>
                         </a:rPr>
-                        <a:t>Richemont</a:t>
+                        <a:t>Hermès</a:t>
                       </a:r>
                     </a:p>
                   </a:txBody>
@@ -10893,7 +10893,7 @@
                           </a:solidFill>
                           <a:latin typeface="Calibri"/>
                         </a:rPr>
-                        <a:t>CFR.SW</a:t>
+                        <a:t>RMS.PA</a:t>
                       </a:r>
                     </a:p>
                   </a:txBody>
@@ -10916,7 +10916,7 @@
                           </a:solidFill>
                           <a:latin typeface="Calibri"/>
                         </a:rPr>
-                        <a:t>52,3</a:t>
+                        <a:t>185,2</a:t>
                       </a:r>
                     </a:p>
                   </a:txBody>
@@ -10939,7 +10939,7 @@
                           </a:solidFill>
                           <a:latin typeface="Calibri"/>
                         </a:rPr>
-                        <a:t>12,8x</a:t>
+                        <a:t>22,1x</a:t>
                       </a:r>
                     </a:p>
                   </a:txBody>
@@ -10962,7 +10962,7 @@
                           </a:solidFill>
                           <a:latin typeface="Calibri"/>
                         </a:rPr>
-                        <a:t>3,5x</a:t>
+                        <a:t>6,8x</a:t>
                       </a:r>
                     </a:p>
                   </a:txBody>
@@ -10985,7 +10985,7 @@
                           </a:solidFill>
                           <a:latin typeface="Calibri"/>
                         </a:rPr>
-                        <a:t>18,5x</a:t>
+                        <a:t>45,6x</a:t>
                       </a:r>
                     </a:p>
                   </a:txBody>
@@ -11008,7 +11008,7 @@
                           </a:solidFill>
                           <a:latin typeface="Calibri"/>
                         </a:rPr>
-                        <a:t>65,0 %</a:t>
+                        <a:t>71,0 %</a:t>
                       </a:r>
                     </a:p>
                   </a:txBody>
@@ -11031,7 +11031,7 @@
                           </a:solidFill>
                           <a:latin typeface="Calibri"/>
                         </a:rPr>
-                        <a:t>31,0 %</a:t>
+                        <a:t>38,0 %</a:t>
                       </a:r>
                     </a:p>
                   </a:txBody>
@@ -11102,7 +11102,7 @@
                           </a:solidFill>
                           <a:latin typeface="Calibri"/>
                         </a:rPr>
-                        <a:t>45,8</a:t>
+                        <a:t>42,1</a:t>
                       </a:r>
                     </a:p>
                   </a:txBody>
@@ -11125,7 +11125,7 @@
                           </a:solidFill>
                           <a:latin typeface="Calibri"/>
                         </a:rPr>
-                        <a:t>14,2x</a:t>
+                        <a:t>10,2x</a:t>
                       </a:r>
                     </a:p>
                   </a:txBody>
@@ -11148,7 +11148,7 @@
                           </a:solidFill>
                           <a:latin typeface="Calibri"/>
                         </a:rPr>
-                        <a:t>3,2x</a:t>
+                        <a:t>2,8x</a:t>
                       </a:r>
                     </a:p>
                   </a:txBody>
@@ -11171,7 +11171,7 @@
                           </a:solidFill>
                           <a:latin typeface="Calibri"/>
                         </a:rPr>
-                        <a:t>25,0x</a:t>
+                        <a:t>22,3x</a:t>
                       </a:r>
                     </a:p>
                   </a:txBody>
@@ -11217,7 +11217,7 @@
                           </a:solidFill>
                           <a:latin typeface="Calibri"/>
                         </a:rPr>
-                        <a:t>25,0 %</a:t>
+                        <a:t>28,0 %</a:t>
                       </a:r>
                     </a:p>
                   </a:txBody>
@@ -11242,7 +11242,7 @@
                           </a:solidFill>
                           <a:latin typeface="Calibri"/>
                         </a:rPr>
-                        <a:t>Prada</a:t>
+                        <a:t>L'Oréal Luxe</a:t>
                       </a:r>
                     </a:p>
                   </a:txBody>
@@ -11265,7 +11265,7 @@
                           </a:solidFill>
                           <a:latin typeface="Calibri"/>
                         </a:rPr>
-                        <a:t>1913.HK</a:t>
+                        <a:t>OR.PA</a:t>
                       </a:r>
                     </a:p>
                   </a:txBody>
@@ -11288,7 +11288,7 @@
                           </a:solidFill>
                           <a:latin typeface="Calibri"/>
                         </a:rPr>
-                        <a:t>12,5</a:t>
+                        <a:t>210,5</a:t>
                       </a:r>
                     </a:p>
                   </a:txBody>
@@ -11311,7 +11311,7 @@
                           </a:solidFill>
                           <a:latin typeface="Calibri"/>
                         </a:rPr>
-                        <a:t>11,8x</a:t>
+                        <a:t>18,7x</a:t>
                       </a:r>
                     </a:p>
                   </a:txBody>
@@ -11334,7 +11334,7 @@
                           </a:solidFill>
                           <a:latin typeface="Calibri"/>
                         </a:rPr>
-                        <a:t>3,1x</a:t>
+                        <a:t>4,5x</a:t>
                       </a:r>
                     </a:p>
                   </a:txBody>
@@ -11357,7 +11357,7 @@
                           </a:solidFill>
                           <a:latin typeface="Calibri"/>
                         </a:rPr>
-                        <a:t>22,0x</a:t>
+                        <a:t>35,1x</a:t>
                       </a:r>
                     </a:p>
                   </a:txBody>
@@ -11380,7 +11380,7 @@
                           </a:solidFill>
                           <a:latin typeface="Calibri"/>
                         </a:rPr>
-                        <a:t>70,0 %</a:t>
+                        <a:t>74,0 %</a:t>
                       </a:r>
                     </a:p>
                   </a:txBody>
@@ -11403,7 +11403,7 @@
                           </a:solidFill>
                           <a:latin typeface="Calibri"/>
                         </a:rPr>
-                        <a:t>27,0 %</a:t>
+                        <a:t>33,0 %</a:t>
                       </a:r>
                     </a:p>
                   </a:txBody>
@@ -11497,7 +11497,7 @@
                           </a:solidFill>
                           <a:latin typeface="Calibri"/>
                         </a:rPr>
-                        <a:t>12,8x</a:t>
+                        <a:t>10,8x</a:t>
                       </a:r>
                     </a:p>
                   </a:txBody>
@@ -11543,7 +11543,7 @@
                           </a:solidFill>
                           <a:latin typeface="Calibri"/>
                         </a:rPr>
-                        <a:t>22,0x</a:t>
+                        <a:t>22,3x</a:t>
                       </a:r>
                     </a:p>
                   </a:txBody>
@@ -11566,7 +11566,7 @@
                           </a:solidFill>
                           <a:latin typeface="Calibri"/>
                         </a:rPr>
-                        <a:t>70,0 %</a:t>
+                        <a:t>71,0 %</a:t>
                       </a:r>
                     </a:p>
                   </a:txBody>
@@ -11589,7 +11589,7 @@
                           </a:solidFill>
                           <a:latin typeface="Calibri"/>
                         </a:rPr>
-                        <a:t>28,0 %</a:t>
+                        <a:t>31,0 %</a:t>
                       </a:r>
                     </a:p>
                   </a:txBody>
@@ -11634,7 +11634,7 @@
                 </a:solidFill>
                 <a:latin typeface="Calibri"/>
               </a:rPr>
-              <a:t>LVMH affiche un EV/EBITDA de 9.2x vs une médiane peers de 11.5x (-20%), justifiée par une croissance supérieure et une marge nette plus élevée. Le P/E à 20.9x est en ligne avec Kering (21.5x) mais inférieur à Hermès (35x). Une convergence vers la médiane peers impliquerait un upside de +15%.</a:t>
+              <a:t>LVMH affiche un EV/EBITDA de 9.2x vs une médiane peers de 11.5x (Kering 8.5x, Richemont 10.8x, Hermès 22.1x, Estée Lauder 10.2x). La décote de 20% est justifiée par une croissance supérieure et une meilleure diversification géographique. Une convergence vers la médiane peers impliquerait un upside de +25% sur l'EV/EBITDA.</a:t>
             </a:r>
           </a:p>
         </p:txBody>
@@ -12292,7 +12292,7 @@
                 </a:solidFill>
                 <a:latin typeface="Calibri"/>
               </a:rPr>
-              <a:t>Avec un WACC de 8.6% et une TGR de 2.5%, le prix implicite DCF est de 520€, soit +13.5% vs le cours actuel. L'upside reflète une sous-valorisation structurelle liée à la qualité des actifs et à la croissance organique. Un catalyseur clé serait une accélération de la demande en Chine.</a:t>
+              <a:t>Avec un WACC de 8.6% et une TGR de 2.5%, le prix implicite DCF est de 520€, soit +13.5% vs le cours actuel de 458.3€. L'upside reflète une sous-valorisation structurelle liée à la résilience des marges et à la reprise en Asie. Un catalyseur clé serait une accélération des ventes en Chine dès 2026.</a:t>
             </a:r>
           </a:p>
         </p:txBody>
@@ -13265,7 +13265,7 @@
                 </a:solidFill>
                 <a:latin typeface="Calibri"/>
               </a:rPr>
-              <a:t>Demande asiatique en chute</a:t>
+              <a:t>Marges sous pression Chine</a:t>
             </a:r>
           </a:p>
         </p:txBody>
@@ -13300,7 +13300,7 @@
                 </a:solidFill>
                 <a:latin typeface="Calibri"/>
               </a:rPr>
-              <a:t>Le pricing power de LVMH repose sur des hausses de prix annuelles de 5 à 10% depuis 2020, mais ces augmentations pourraient s'essouffler face à une demande asiatique en repli : les ventes en Chine ont chuté de 14% en 2024, menaçant 28% du CA. Les marges brutes à 66,2% sont artificiellement gonflées par des coûts fixes élevés, avec une hausse des stocks invendus de…</a:t>
+              <a:t>La marge brute de 66.2% repose sur un mix produit déséquilibré avec 45% des ventes en maroquinerie, secteur déjà en surcapacité en Chine où les stocks ont augmenté de 22% en 2023, menaçant les prix.</a:t>
             </a:r>
           </a:p>
         </p:txBody>
@@ -13421,7 +13421,7 @@
                 </a:solidFill>
                 <a:latin typeface="Calibri"/>
               </a:rPr>
-              <a:t>Saturation du réseau</a:t>
+              <a:t>Endettement masqué</a:t>
             </a:r>
           </a:p>
         </p:txBody>
@@ -13456,7 +13456,7 @@
                 </a:solidFill>
                 <a:latin typeface="Calibri"/>
               </a:rPr>
-              <a:t>Le réseau exclusif, pilier de la marque, montre des signes de saturation : 5 100 boutiques en 2025 contre 4 200 en 2020, diluant l'expérience client et augmentant les coûts d'exploitation de 8% par an. Les ventes en ligne, en croissance de 15% en 2024, ne compensent pas la baisse de fréquentation en magasin, avec un panier moyen en baisse de 7%.</a:t>
+              <a:t>Le ROE de 16.1% est gonflé par un endettement artificiellement bas grâce à des rachats d'actions pour 12 milliards d'euros en 2022, masquant une rentabilité opérationnelle réelle de 14.2%.</a:t>
             </a:r>
           </a:p>
         </p:txBody>
@@ -13577,7 +13577,7 @@
                 </a:solidFill>
                 <a:latin typeface="Calibri"/>
               </a:rPr>
-              <a:t>Dépendance au luxe cyclique</a:t>
+              <a:t>Croissance marges illusoire</a:t>
             </a:r>
           </a:p>
         </p:txBody>
@@ -13612,7 +13612,7 @@
                 </a:solidFill>
                 <a:latin typeface="Calibri"/>
               </a:rPr>
-              <a:t>La diversification géographique et sectorielle (vins, spiritueux, mode) masque une dépendance croissante au segment mode, qui représente désormais 52% du CA contre 45% en 2020. Ce segment, plus cyclique, est exposé à une récession en Europe (-3% de croissance prévue en 2025) et à une guerre des prix avec les marques de luxe accessibles comme Coach ou Michael Kors.…</a:t>
+              <a:t>L'EV/EBITDA à 9.24x suppose une croissance perpétuelle des marges, mais les coûts logistiques ont bondi de 18% en 2023, réduisant les marges nettes à 12.8% en glissement annuel.</a:t>
             </a:r>
           </a:p>
         </p:txBody>
@@ -13826,7 +13826,7 @@
                           </a:solidFill>
                           <a:latin typeface="Calibri"/>
                         </a:rPr>
-                        <a:t>Croissance Chine &lt;3% en 2026</a:t>
+                        <a:t>Croissance Chine &lt;3% en 2026 avec dépréciation du yuan de 10%</a:t>
                       </a:r>
                     </a:p>
                   </a:txBody>
@@ -13897,7 +13897,7 @@
                           </a:solidFill>
                           <a:latin typeface="Calibri"/>
                         </a:rPr>
-                        <a:t>Concurrence accrue des marques émergentes</a:t>
+                        <a:t>Concurrence accrue des marques coréennes et japonaises sur le segment premium</a:t>
                       </a:r>
                     </a:p>
                   </a:txBody>
@@ -13968,7 +13968,7 @@
                           </a:solidFill>
                           <a:latin typeface="Calibri"/>
                         </a:rPr>
-                        <a:t>Perte de parts de marché chez Louis Vuitton</a:t>
+                        <a:t>Perte de parts de marché en Chine pour Louis Vuitton &gt;5% en 2026</a:t>
                       </a:r>
                     </a:p>
                   </a:txBody>
@@ -15858,7 +15858,7 @@
                           </a:solidFill>
                           <a:latin typeface="Calibri"/>
                         </a:rPr>
-                        <a:t>Rebond de la demande chinoise post-Covid avec +15% CA 2026 | Hausse des prix de 8-10% sur les produits phares | Horizon 12-18 mois, Expansion du e-commerce avec +25% CA digital en 2026 | Marges digitales supérieures de 10pp | Horizon 6-12 mois, Acquisitions ciblées dans le lifestyle (ex: Tiffany) avec ROI attendu &gt;15% | Horizon 18-24 mois</a:t>
+                        <a:t>Rebond des ventes en Chine +15% en 2026 avec effet volume et mix positif | Hausse des prix de 8% en 2026 sur les produits iconiques | Expansion des marges…</a:t>
                       </a:r>
                     </a:p>
                   </a:txBody>
@@ -16046,7 +16046,7 @@
                           </a:solidFill>
                           <a:latin typeface="Calibri"/>
                         </a:rPr>
-                        <a:t>Ralentissement économique en Chine avec -5% CA local en 2026 | Impact sur les ventes de montres et maroquinerie | Horizon 6-12 mois, Concurrence accrue de marques émergentes (ex: Richemont) avec perte de parts de marché | Pression sur les prix | Horizon 12-18 mois, Risque réglementaire en Europe avec +10% taxes sur les produits de luxe | Baisse de la demande locale | Horizon 12-24 mois</a:t>
+                        <a:t>Ralentissement économique en Chine -5% en 2026 avec impact sur les ventes de 12% | Concurrence accrue des marques asiatiques sur le segment premium | Hausse…</a:t>
                       </a:r>
                     </a:p>
                   </a:txBody>
@@ -16069,7 +16069,7 @@
         </p:nvSpPr>
         <p:spPr>
           <a:xfrm>
-            <a:off x="367200" y="3664800"/>
+            <a:off x="367200" y="4140000"/>
             <a:ext cx="8413200" cy="914400"/>
           </a:xfrm>
           <a:prstGeom prst="rect">
@@ -19029,7 +19029,7 @@
                 </a:solidFill>
                 <a:latin typeface="Calibri"/>
               </a:rPr>
-              <a:t>LVMH se négocie à 9.2x EV/EBITDA vs une médiane peers à 11.5x, offrant une décote de 20%. Le P/E à 20.9x reste justifié par la qualité des actifs et la croissance supérieure.</a:t>
+              <a:t>LVMH se négocie à 9.2x EV/EBITDA vs une médiane peers à 11.5x, soit une décote de 20%. Le P/E de 20.9x reflète une prime de qualité justifiée par la résilience des marges.</a:t>
             </a:r>
           </a:p>
         </p:txBody>
@@ -19359,7 +19359,7 @@
                 </a:solidFill>
                 <a:latin typeface="Calibri"/>
               </a:rPr>
-              <a:t>Prix cible base : 520 EUR  ·  Upside : +13,5 %  ·  Bear : 440 EUR (-4,0 %)  ·  Bull : 580 EUR (+26,6 %)</a:t>
+              <a:t>Prix cible base : 520 EUR  ·  Upside : +13,5 %  ·  Bear : 460 EUR (+0,4 %)  ·  Bull : 580 EUR (+26,6 %)</a:t>
             </a:r>
           </a:p>
         </p:txBody>
@@ -19515,7 +19515,7 @@
                 </a:solidFill>
                 <a:latin typeface="Calibri"/>
               </a:rPr>
-              <a:t>Pricing power</a:t>
+              <a:t>Pricing Power</a:t>
             </a:r>
           </a:p>
         </p:txBody>
@@ -19550,7 +19550,7 @@
                 </a:solidFill>
                 <a:latin typeface="Calibri"/>
               </a:rPr>
-              <a:t>LVMH devrait bénéficier d'une reprise de la demande chinoise post-Covid avec +15% de croissance CA en 2026</a:t>
+              <a:t>LVMH devrait bénéficier d'un rebond des ventes en Chine +15% en 2026 après 3 ans de contraction</a:t>
             </a:r>
           </a:p>
         </p:txBody>
@@ -19628,7 +19628,7 @@
                 </a:solidFill>
                 <a:latin typeface="Calibri"/>
               </a:rPr>
-              <a:t>Réseau exclusif</a:t>
+              <a:t>Réseau Distribution</a:t>
             </a:r>
           </a:p>
         </p:txBody>
@@ -19663,7 +19663,7 @@
                 </a:solidFill>
                 <a:latin typeface="Calibri"/>
               </a:rPr>
-              <a:t>La marge EBITDA devrait se stabiliser à 33% grâce à un mix produit favorable et une discipline des coûts</a:t>
+              <a:t>La marge EBITDA devrait se stabiliser à 33% en 2027 grâce à l'optimisation des coûts logistiques et à la hausse des prix</a:t>
             </a:r>
           </a:p>
         </p:txBody>
@@ -19741,7 +19741,7 @@
                 </a:solidFill>
                 <a:latin typeface="Calibri"/>
               </a:rPr>
-              <a:t>Diversification</a:t>
+              <a:t>Marques Iconiques</a:t>
             </a:r>
           </a:p>
         </p:txBody>
@@ -19776,7 +19776,7 @@
                 </a:solidFill>
                 <a:latin typeface="Calibri"/>
               </a:rPr>
-              <a:t>Le cash-flow libre devrait atteindre 12Md€ en 2026, soutenant des rachats d'actions et des dividendes en hausse.</a:t>
+              <a:t>Le groupe pourrait atteindre 85 milliards d'euros de CA en 2026, soit +5.5% vs 2025, avec un effet de levier opérationnel de 1.8x</a:t>
             </a:r>
           </a:p>
         </p:txBody>
@@ -19967,7 +19967,7 @@
                 </a:solidFill>
                 <a:latin typeface="Calibri"/>
               </a:rPr>
-              <a:t>Ralentissement économique en Chine avec -5% CA local en 2026 | Impact sur les ventes de montres et maroquinerie | Horizon 6-12 mois</a:t>
+              <a:t>Ralentissement économique en Chine -5% en 2026 avec impact sur les ventes de 12% | Concurrence accrue des marques asiatiques sur le segment premium | Hausse des coûts de production +10% en 2026 due à…</a:t>
             </a:r>
           </a:p>
         </p:txBody>
@@ -20045,7 +20045,7 @@
                 </a:solidFill>
                 <a:latin typeface="Calibri"/>
               </a:rPr>
-              <a:t>Concurrence</a:t>
+              <a:t>Concurrence Asiatique</a:t>
             </a:r>
           </a:p>
         </p:txBody>
@@ -20080,7 +20080,7 @@
                 </a:solidFill>
                 <a:latin typeface="Calibri"/>
               </a:rPr>
-              <a:t>Concurrence accrue de marques émergentes (ex: Richemont) avec perte de parts de marché | Pression sur les prix | Horizon 12-18 mois</a:t>
+              <a:t>Le ROE de 16.1% est gonflé par un endettement artificiellement bas grâce à des rachats d'actions pour 12 milliards d'euros en 2022, masquant une rentabilité opérationnelle réelle de 14.2%.</a:t>
             </a:r>
           </a:p>
         </p:txBody>
@@ -20158,7 +20158,7 @@
                 </a:solidFill>
                 <a:latin typeface="Calibri"/>
               </a:rPr>
-              <a:t>Risque réglementaire</a:t>
+              <a:t>Risque Réglementaire</a:t>
             </a:r>
           </a:p>
         </p:txBody>
@@ -20193,7 +20193,7 @@
                 </a:solidFill>
                 <a:latin typeface="Calibri"/>
               </a:rPr>
-              <a:t>Risque réglementaire en Europe avec +10% taxes sur les produits de luxe | Baisse de la demande locale | Horizon 12-24 mois</a:t>
+              <a:t>L'EV/EBITDA à 9.24x suppose une croissance perpétuelle des marges, mais les coûts logistiques ont bondi de 18% en 2023, réduisant les marges nettes à 12.8% en glissement annuel.</a:t>
             </a:r>
           </a:p>
         </p:txBody>
@@ -20470,7 +20470,7 @@
                 </a:solidFill>
                 <a:latin typeface="Calibri"/>
               </a:rPr>
-              <a:t>vs 12,8x médiane peers</a:t>
+              <a:t>vs 10,8x médiane peers</a:t>
             </a:r>
           </a:p>
         </p:txBody>
@@ -23672,7 +23672,7 @@
                 </a:solidFill>
                 <a:latin typeface="Calibri"/>
               </a:rPr>
-              <a:t>LVMH affiche une résilience exceptionnelle malgré un environnement macro difficile, avec des marges historiques élevées et une trésorerie solide. La diversification géographique et sectorielle limite les risques tout en captant la demande asiatique et américaine.</a:t>
+              <a:t>LVMH affiche une résilience opérationnelle malgré un environnement macroéconomique dégradé, avec des marges nettes en légère érosion mais une trésorerie solide. Le groupe reste un leader incontesté du luxe, porté par son mix géographique et son pouvoir de pricing exceptionnel.</a:t>
             </a:r>
           </a:p>
         </p:txBody>
@@ -24715,7 +24715,7 @@
                 </a:solidFill>
                 <a:latin typeface="Calibri"/>
               </a:rPr>
-              <a:t>Ralentissement Chine  ·  Concurrence</a:t>
+              <a:t>Ralentissement Chine  ·  Concurrence Asiatique</a:t>
             </a:r>
           </a:p>
         </p:txBody>
@@ -25949,7 +25949,7 @@
                 </a:solidFill>
                 <a:latin typeface="Calibri"/>
               </a:rPr>
-              <a:t>LVMH est le leader mondial du luxe avec un portefeuille de 75 Maisons emblématiques couvrant mode, vins &amp; spiritueux, parfums et montres. Positionné sur le segment premium avec une stratégie de rareté et d'exclusivité, le groupe bénéficie d'un pricing power inégalé et d'une clientèle fidèle. Ses avantages concurrentiels incluent une gestion centralisée des coûts, une innovation constante et un réseau de distribution ultra-contrôlé. L'entreprise articule son activité autour de deux segments stratégiques :</a:t>
+              <a:t>LVMH est le leader mondial du luxe avec un portefeuille de 75 Maisons couvrant mode, vins &amp; spiritueux, montres &amp; joaillerie et parfums. Positionné sur le segment ultra-premium, le groupe cible une clientèle aisée mondiale avec des produits à forte valeur ajoutée. Ses avantages concurrentiels incluent un écosystème intégré, une marque omnicanale et une capacité d'innovation inégalée dans l'industrie. L'entreprise articule son activité autour de deux segments stratégiques :</a:t>
             </a:r>
           </a:p>
         </p:txBody>
@@ -26062,7 +26062,7 @@
                 </a:solidFill>
                 <a:latin typeface="Calibri"/>
               </a:rPr>
-              <a:t>Segment phare générant 50% du CA avec des marques comme Louis Vuitton et Dior. Modèle basé sur la rareté, le storytelling et le contrôle strict de la distribution. Clients cibles : ultra-riches et touristes asiatiques. Moteurs : expansion en Chine (+15% CA 2025) et relance du tourisme post-Covid.</a:t>
+              <a:t>Segment phare avec des marques comme Louis Vuitton et Dior, générant 45% du CA. Modèle basé sur des produits iconiques à forte marge, une distribution sélective et une stratégie de rareté contrôlée. Clients cibles : consommateurs asiatiques et américains avec panier moyen élevé. Croissance portée par l'expansion en…</a:t>
             </a:r>
           </a:p>
         </p:txBody>
@@ -26175,7 +26175,7 @@
                 </a:solidFill>
                 <a:latin typeface="Calibri"/>
               </a:rPr>
-              <a:t>2e segment en taille avec des marques comme Moët &amp; Chandon et Hennessy. Modèle de revenus récurrents via la vente de bouteilles et l'expérience client. Clients cibles : amateurs de luxe et collectionneurs. Moteurs : croissance en Asie (+12% CA 2025) et premiumisation des gammes.</a:t>
+              <a:t>Segment historique avec Moët Hennessy et Hennessy, contribuant à 25% du CA. Modèle basé sur des marques premium avec pricing power et fidélisation client. Produits phares : champagne Moët &amp; Chandon et cognac Hennessy. Clients cibles : consommateurs asiatiques et américains avec demande stable en volume mais croissance…</a:t>
             </a:r>
           </a:p>
         </p:txBody>
@@ -27554,7 +27554,7 @@
                 </a:solidFill>
                 <a:latin typeface="Calibri"/>
               </a:rPr>
-              <a:t>50%</a:t>
+              <a:t>45%</a:t>
             </a:r>
           </a:p>
         </p:txBody>
@@ -27702,7 +27702,7 @@
                 </a:solidFill>
                 <a:latin typeface="Calibri"/>
               </a:rPr>
-              <a:t>Segment phare générant 50% du CA avec des marques comme Louis Vuitton et Dior. Modèle basé sur la rareté, le storytelling et le contrôle strict de la distribution. Clients cibles : ultra-riches et touristes asiatiques. Moteurs : expansion en Chine (+15% CA 2025) et relance du tourisme post-Covid.</a:t>
+              <a:t>Segment phare avec des marques comme Louis Vuitton et Dior, générant 45% du CA. Modèle basé sur des produits iconiques à forte marge, une distribution sélective et une stratégie de rareté contrôlée. Clients cibles : consommateurs asiatiques et américains avec panier moyen élevé. Croissance portée par l'expansion en Chine et l'innovation produit (ex: collaborations limitées).</a:t>
             </a:r>
           </a:p>
         </p:txBody>
@@ -27971,7 +27971,7 @@
                 </a:solidFill>
                 <a:latin typeface="Calibri"/>
               </a:rPr>
-              <a:t>2e segment en taille avec des marques comme Moët &amp; Chandon et Hennessy. Modèle de revenus récurrents via la vente de bouteilles et l'expérience client. Clients cibles : amateurs de luxe et collectionneurs. Moteurs : croissance en Asie (+12% CA 2025) et premiumisation des gammes.</a:t>
+              <a:t>Segment historique avec Moët Hennessy et Hennessy, contribuant à 25% du CA. Modèle basé sur des marques premium avec pricing power et fidélisation client. Produits phares : champagne Moët &amp; Chandon et cognac Hennessy. Clients cibles : consommateurs asiatiques et américains avec demande stable en volume mais croissance en valeur via premiumisation.</a:t>
             </a:r>
           </a:p>
         </p:txBody>
@@ -29100,7 +29100,7 @@
                           </a:solidFill>
                           <a:latin typeface="Calibri"/>
                         </a:rPr>
-                        <a:t>89,0</a:t>
+                        <a:t>85,0</a:t>
                       </a:r>
                     </a:p>
                   </a:txBody>
@@ -29123,7 +29123,7 @@
                           </a:solidFill>
                           <a:latin typeface="Calibri"/>
                         </a:rPr>
-                        <a:t>96,0</a:t>
+                        <a:t>90,0</a:t>
                       </a:r>
                     </a:p>
                   </a:txBody>
@@ -29240,7 +29240,7 @@
                           </a:solidFill>
                           <a:latin typeface="Calibri"/>
                         </a:rPr>
-                        <a:t>+10,2 %</a:t>
+                        <a:t>+5,5 %</a:t>
                       </a:r>
                     </a:p>
                   </a:txBody>
@@ -29263,7 +29263,7 @@
                           </a:solidFill>
                           <a:latin typeface="Calibri"/>
                         </a:rPr>
-                        <a:t>+7,9 %</a:t>
+                        <a:t>+5,9 %</a:t>
                       </a:r>
                     </a:p>
                   </a:txBody>
@@ -29380,7 +29380,7 @@
                           </a:solidFill>
                           <a:latin typeface="Calibri"/>
                         </a:rPr>
-                        <a:t>59,6</a:t>
+                        <a:t>57,0</a:t>
                       </a:r>
                     </a:p>
                   </a:txBody>
@@ -29403,7 +29403,7 @@
                           </a:solidFill>
                           <a:latin typeface="Calibri"/>
                         </a:rPr>
-                        <a:t>64,8</a:t>
+                        <a:t>60,8</a:t>
                       </a:r>
                     </a:p>
                   </a:txBody>
@@ -29660,7 +29660,7 @@
                           </a:solidFill>
                           <a:latin typeface="Calibri"/>
                         </a:rPr>
-                        <a:t>29,4</a:t>
+                        <a:t>28,1</a:t>
                       </a:r>
                     </a:p>
                   </a:txBody>
@@ -29683,7 +29683,7 @@
                           </a:solidFill>
                           <a:latin typeface="Calibri"/>
                         </a:rPr>
-                        <a:t>32,2</a:t>
+                        <a:t>30,6</a:t>
                       </a:r>
                     </a:p>
                   </a:txBody>
@@ -29823,7 +29823,7 @@
                           </a:solidFill>
                           <a:latin typeface="Calibri"/>
                         </a:rPr>
-                        <a:t>33,5 %</a:t>
+                        <a:t>34,0 %</a:t>
                       </a:r>
                     </a:p>
                   </a:txBody>
@@ -29940,7 +29940,7 @@
                           </a:solidFill>
                           <a:latin typeface="Calibri"/>
                         </a:rPr>
-                        <a:t>12,0</a:t>
+                        <a:t>11,9</a:t>
                       </a:r>
                     </a:p>
                   </a:txBody>
@@ -29963,7 +29963,7 @@
                           </a:solidFill>
                           <a:latin typeface="Calibri"/>
                         </a:rPr>
-                        <a:t>13,2</a:t>
+                        <a:t>13,5</a:t>
                       </a:r>
                     </a:p>
                   </a:txBody>
@@ -30080,7 +30080,7 @@
                           </a:solidFill>
                           <a:latin typeface="Calibri"/>
                         </a:rPr>
-                        <a:t>13,5 %</a:t>
+                        <a:t>14,0 %</a:t>
                       </a:r>
                     </a:p>
                   </a:txBody>
@@ -30103,7 +30103,7 @@
                           </a:solidFill>
                           <a:latin typeface="Calibri"/>
                         </a:rPr>
-                        <a:t>13,8 %</a:t>
+                        <a:t>15,0 %</a:t>
                       </a:r>
                     </a:p>
                   </a:txBody>
@@ -30148,7 +30148,7 @@
                 </a:solidFill>
                 <a:latin typeface="Calibri"/>
               </a:rPr>
-              <a:t>Le CA 2025 recule de -4.6% YoY mais les marges restent robustes (GM 66.2%, EBITDA 32%). La résilience s'explique par un levier opérationnel de 15% et une discipline des coûts. Le cash-flow libre de 10.5Md€ renforce la solidité bilancielle, permettant de financer des acquisitions ciblées.</a:t>
+              <a:t>Le CA 2025 affiche une baisse de -4.6% YoY mais les marges restent robustes (GM 66.2%, EBITDA 32%). La contraction des marges nettes (-430bps vs 2022) s'explique par des coûts logistiques élevés et des investissements marketing en Chine. Le levier opérationnel de 1.6x et la discipline sur les coûts soutiennent la génération de cash (FCF 2025: 12.5 milliards d'euros).</a:t>
             </a:r>
           </a:p>
         </p:txBody>
@@ -32065,7 +32065,7 @@
                 </a:solidFill>
                 <a:latin typeface="Calibri"/>
               </a:rPr>
-              <a:t>Le CA 2025 recule de -4.6% YoY mais les marges restent robustes (GM 66.2%, EBITDA 32%). La résilience s'explique par un levier opérationnel de 15% et une discipline des coûts. Le cash-flow libre de 10.5Md€ renforce la solidité bilancielle, permettant de financer des acquisitions ciblées.</a:t>
+              <a:t>Le CA 2025 affiche une baisse de -4.6% YoY mais les marges restent robustes (GM 66.2%, EBITDA 32%). La contraction des marges nettes (-430bps vs 2022) s'explique par des coûts logistiques élevés et des investissements marketing en Chine. Le levier opérationnel de 1.6x et la discipline sur les coûts </a:t>
             </a:r>
           </a:p>
         </p:txBody>

</xml_diff>